<commit_message>
chatbot css to be done
</commit_message>
<xml_diff>
--- a/ROADMAP/roadmap react js.pptx
+++ b/ROADMAP/roadmap react js.pptx
@@ -264,7 +264,7 @@
           <a:p>
             <a:fld id="{3757B9D6-B1DD-42FC-8CF6-CEEED335747B}" type="datetimeFigureOut">
               <a:rPr lang="en-IN" smtClean="0"/>
-              <a:t>08-01-2026</a:t>
+              <a:t>13-01-2026</a:t>
             </a:fld>
             <a:endParaRPr lang="en-IN"/>
           </a:p>
@@ -464,7 +464,7 @@
           <a:p>
             <a:fld id="{3757B9D6-B1DD-42FC-8CF6-CEEED335747B}" type="datetimeFigureOut">
               <a:rPr lang="en-IN" smtClean="0"/>
-              <a:t>08-01-2026</a:t>
+              <a:t>13-01-2026</a:t>
             </a:fld>
             <a:endParaRPr lang="en-IN"/>
           </a:p>
@@ -674,7 +674,7 @@
           <a:p>
             <a:fld id="{3757B9D6-B1DD-42FC-8CF6-CEEED335747B}" type="datetimeFigureOut">
               <a:rPr lang="en-IN" smtClean="0"/>
-              <a:t>08-01-2026</a:t>
+              <a:t>13-01-2026</a:t>
             </a:fld>
             <a:endParaRPr lang="en-IN"/>
           </a:p>
@@ -874,7 +874,7 @@
           <a:p>
             <a:fld id="{3757B9D6-B1DD-42FC-8CF6-CEEED335747B}" type="datetimeFigureOut">
               <a:rPr lang="en-IN" smtClean="0"/>
-              <a:t>08-01-2026</a:t>
+              <a:t>13-01-2026</a:t>
             </a:fld>
             <a:endParaRPr lang="en-IN"/>
           </a:p>
@@ -1150,7 +1150,7 @@
           <a:p>
             <a:fld id="{3757B9D6-B1DD-42FC-8CF6-CEEED335747B}" type="datetimeFigureOut">
               <a:rPr lang="en-IN" smtClean="0"/>
-              <a:t>08-01-2026</a:t>
+              <a:t>13-01-2026</a:t>
             </a:fld>
             <a:endParaRPr lang="en-IN"/>
           </a:p>
@@ -1418,7 +1418,7 @@
           <a:p>
             <a:fld id="{3757B9D6-B1DD-42FC-8CF6-CEEED335747B}" type="datetimeFigureOut">
               <a:rPr lang="en-IN" smtClean="0"/>
-              <a:t>08-01-2026</a:t>
+              <a:t>13-01-2026</a:t>
             </a:fld>
             <a:endParaRPr lang="en-IN"/>
           </a:p>
@@ -1833,7 +1833,7 @@
           <a:p>
             <a:fld id="{3757B9D6-B1DD-42FC-8CF6-CEEED335747B}" type="datetimeFigureOut">
               <a:rPr lang="en-IN" smtClean="0"/>
-              <a:t>08-01-2026</a:t>
+              <a:t>13-01-2026</a:t>
             </a:fld>
             <a:endParaRPr lang="en-IN"/>
           </a:p>
@@ -1975,7 +1975,7 @@
           <a:p>
             <a:fld id="{3757B9D6-B1DD-42FC-8CF6-CEEED335747B}" type="datetimeFigureOut">
               <a:rPr lang="en-IN" smtClean="0"/>
-              <a:t>08-01-2026</a:t>
+              <a:t>13-01-2026</a:t>
             </a:fld>
             <a:endParaRPr lang="en-IN"/>
           </a:p>
@@ -2088,7 +2088,7 @@
           <a:p>
             <a:fld id="{3757B9D6-B1DD-42FC-8CF6-CEEED335747B}" type="datetimeFigureOut">
               <a:rPr lang="en-IN" smtClean="0"/>
-              <a:t>08-01-2026</a:t>
+              <a:t>13-01-2026</a:t>
             </a:fld>
             <a:endParaRPr lang="en-IN"/>
           </a:p>
@@ -2401,7 +2401,7 @@
           <a:p>
             <a:fld id="{3757B9D6-B1DD-42FC-8CF6-CEEED335747B}" type="datetimeFigureOut">
               <a:rPr lang="en-IN" smtClean="0"/>
-              <a:t>08-01-2026</a:t>
+              <a:t>13-01-2026</a:t>
             </a:fld>
             <a:endParaRPr lang="en-IN"/>
           </a:p>
@@ -2690,7 +2690,7 @@
           <a:p>
             <a:fld id="{3757B9D6-B1DD-42FC-8CF6-CEEED335747B}" type="datetimeFigureOut">
               <a:rPr lang="en-IN" smtClean="0"/>
-              <a:t>08-01-2026</a:t>
+              <a:t>13-01-2026</a:t>
             </a:fld>
             <a:endParaRPr lang="en-IN"/>
           </a:p>
@@ -2933,7 +2933,7 @@
           <a:p>
             <a:fld id="{3757B9D6-B1DD-42FC-8CF6-CEEED335747B}" type="datetimeFigureOut">
               <a:rPr lang="en-IN" smtClean="0"/>
-              <a:t>08-01-2026</a:t>
+              <a:t>13-01-2026</a:t>
             </a:fld>
             <a:endParaRPr lang="en-IN"/>
           </a:p>
@@ -3825,7 +3825,7 @@
             <p:ph idx="1"/>
             <p:extLst>
               <p:ext uri="{D42A27DB-BD31-4B8C-83A1-F6EECF244321}">
-                <p14:modId xmlns:p14="http://schemas.microsoft.com/office/powerpoint/2010/main" val="3573853326"/>
+                <p14:modId xmlns:p14="http://schemas.microsoft.com/office/powerpoint/2010/main" val="497159379"/>
               </p:ext>
             </p:extLst>
           </p:nvPr>
@@ -4238,6 +4238,19 @@
                     <a:lstStyle/>
                     <a:p>
                       <a:pPr algn="ctr" fontAlgn="b"/>
+                      <a:r>
+                        <a:rPr lang="en-IN" sz="1400" b="0" i="0" u="none" strike="noStrike" dirty="0">
+                          <a:solidFill>
+                            <a:srgbClr val="000000"/>
+                          </a:solidFill>
+                          <a:effectLst/>
+                          <a:latin typeface="Aptos Narrow"/>
+                        </a:rPr>
+                        <a:t>DONE</a:t>
+                      </a:r>
+                    </a:p>
+                    <a:p>
+                      <a:pPr algn="ctr" fontAlgn="b"/>
                       <a:endParaRPr lang="en-IN" sz="1400" b="0" i="0" u="none" strike="noStrike" dirty="0">
                         <a:solidFill>
                           <a:srgbClr val="000000"/>
@@ -4252,6 +4265,120 @@
                 <a:extLst>
                   <a:ext uri="{0D108BD9-81ED-4DB2-BD59-A6C34878D82A}">
                     <a16:rowId xmlns:a16="http://schemas.microsoft.com/office/drawing/2014/main" val="3070809323"/>
+                  </a:ext>
+                </a:extLst>
+              </a:tr>
+              <a:tr h="282909">
+                <a:tc>
+                  <a:txBody>
+                    <a:bodyPr/>
+                    <a:lstStyle/>
+                    <a:p>
+                      <a:pPr algn="l" fontAlgn="b"/>
+                      <a:r>
+                        <a:rPr lang="en-IN" sz="1400" u="none" strike="noStrike" dirty="0">
+                          <a:effectLst/>
+                        </a:rPr>
+                        <a:t> </a:t>
+                      </a:r>
+                      <a:endParaRPr lang="en-IN" sz="1400" b="0" i="0" u="none" strike="noStrike" dirty="0">
+                        <a:solidFill>
+                          <a:srgbClr val="000000"/>
+                        </a:solidFill>
+                        <a:effectLst/>
+                        <a:latin typeface="Aptos Narrow"/>
+                      </a:endParaRPr>
+                    </a:p>
+                  </a:txBody>
+                  <a:tcPr marL="7620" marR="7620" marT="7620" marB="0" anchor="b"/>
+                </a:tc>
+                <a:tc vMerge="1">
+                  <a:txBody>
+                    <a:bodyPr/>
+                    <a:lstStyle/>
+                    <a:p>
+                      <a:endParaRPr lang="en-IN"/>
+                    </a:p>
+                  </a:txBody>
+                  <a:tcPr/>
+                </a:tc>
+                <a:tc vMerge="1">
+                  <a:txBody>
+                    <a:bodyPr/>
+                    <a:lstStyle/>
+                    <a:p>
+                      <a:endParaRPr lang="en-IN"/>
+                    </a:p>
+                  </a:txBody>
+                  <a:tcPr/>
+                </a:tc>
+                <a:extLst>
+                  <a:ext uri="{0D108BD9-81ED-4DB2-BD59-A6C34878D82A}">
+                    <a16:rowId xmlns:a16="http://schemas.microsoft.com/office/drawing/2014/main" val="1331713220"/>
+                  </a:ext>
+                </a:extLst>
+              </a:tr>
+              <a:tr h="282909">
+                <a:tc>
+                  <a:txBody>
+                    <a:bodyPr/>
+                    <a:lstStyle/>
+                    <a:p>
+                      <a:pPr algn="l" fontAlgn="b"/>
+                      <a:r>
+                        <a:rPr lang="en-IN" sz="1400" u="none" strike="noStrike" dirty="0">
+                          <a:effectLst/>
+                        </a:rPr>
+                        <a:t> </a:t>
+                      </a:r>
+                      <a:endParaRPr lang="en-IN" sz="1400" b="0" i="0" u="none" strike="noStrike" dirty="0">
+                        <a:solidFill>
+                          <a:srgbClr val="000000"/>
+                        </a:solidFill>
+                        <a:effectLst/>
+                        <a:latin typeface="Aptos Narrow"/>
+                      </a:endParaRPr>
+                    </a:p>
+                  </a:txBody>
+                  <a:tcPr marL="7620" marR="7620" marT="7620" marB="0" anchor="b"/>
+                </a:tc>
+                <a:tc>
+                  <a:txBody>
+                    <a:bodyPr/>
+                    <a:lstStyle/>
+                    <a:p>
+                      <a:pPr algn="l" fontAlgn="b"/>
+                      <a:endParaRPr lang="en-IN" sz="1400" b="0" i="0" u="none" strike="noStrike" dirty="0">
+                        <a:solidFill>
+                          <a:srgbClr val="000000"/>
+                        </a:solidFill>
+                        <a:effectLst/>
+                        <a:latin typeface="Aptos Narrow"/>
+                      </a:endParaRPr>
+                    </a:p>
+                  </a:txBody>
+                  <a:tcPr marL="7620" marR="7620" marT="7620" marB="0" anchor="b"/>
+                </a:tc>
+                <a:tc>
+                  <a:txBody>
+                    <a:bodyPr/>
+                    <a:lstStyle/>
+                    <a:p>
+                      <a:pPr algn="l" fontAlgn="b"/>
+                      <a:endParaRPr lang="en-IN" sz="1400" b="0" i="0" u="none" strike="noStrike" dirty="0">
+                        <a:solidFill>
+                          <a:srgbClr val="000000"/>
+                        </a:solidFill>
+                        <a:effectLst/>
+                        <a:latin typeface="Aptos Narrow"/>
+                      </a:endParaRPr>
+                    </a:p>
+                  </a:txBody>
+                  <a:tcPr marL="7620" marR="7620" marT="7620" marB="0" anchor="b"/>
+                </a:tc>
+                <a:extLst>
+                  <a:ext uri="{0D108BD9-81ED-4DB2-BD59-A6C34878D82A}">
+                    <a16:rowId xmlns:a16="http://schemas.microsoft.com/office/drawing/2014/main" val="1368431794"/>
                   </a:ext>
                 </a:extLst>
               </a:tr>
@@ -4283,124 +4410,6 @@
                   </a:txBody>
                   <a:tcPr marL="7620" marR="7620" marT="7620" marB="0" anchor="b"/>
                 </a:tc>
-                <a:tc vMerge="1">
-                  <a:txBody>
-                    <a:bodyPr/>
-                    <a:lstStyle/>
-                    <a:p>
-                      <a:endParaRPr lang="en-IN"/>
-                    </a:p>
-                  </a:txBody>
-                  <a:tcPr/>
-                </a:tc>
-                <a:tc vMerge="1">
-                  <a:txBody>
-                    <a:bodyPr/>
-                    <a:lstStyle/>
-                    <a:p>
-                      <a:endParaRPr lang="en-IN"/>
-                    </a:p>
-                  </a:txBody>
-                  <a:tcPr/>
-                </a:tc>
-                <a:extLst>
-                  <a:ext uri="{0D108BD9-81ED-4DB2-BD59-A6C34878D82A}">
-                    <a16:rowId xmlns:a16="http://schemas.microsoft.com/office/drawing/2014/main" val="1331713220"/>
-                  </a:ext>
-                </a:extLst>
-              </a:tr>
-              <a:tr h="282909">
-                <a:tc>
-                  <a:txBody>
-                    <a:bodyPr/>
-                    <a:lstStyle/>
-                    <a:p>
-                      <a:pPr algn="l" fontAlgn="b"/>
-                      <a:r>
-                        <a:rPr lang="en-IN" sz="1400" u="none" strike="noStrike" dirty="0">
-                          <a:effectLst/>
-                        </a:rPr>
-                        <a:t> </a:t>
-                      </a:r>
-                      <a:endParaRPr lang="en-IN" sz="1400" b="0" i="0" u="none" strike="noStrike" dirty="0">
-                        <a:solidFill>
-                          <a:srgbClr val="000000"/>
-                        </a:solidFill>
-                        <a:effectLst/>
-                        <a:latin typeface="Aptos Narrow"/>
-                      </a:endParaRPr>
-                    </a:p>
-                  </a:txBody>
-                  <a:tcPr marL="7620" marR="7620" marT="7620" marB="0" anchor="b"/>
-                </a:tc>
-                <a:tc>
-                  <a:txBody>
-                    <a:bodyPr/>
-                    <a:lstStyle/>
-                    <a:p>
-                      <a:pPr algn="l" fontAlgn="b"/>
-                      <a:endParaRPr lang="en-IN" sz="1400" b="0" i="0" u="none" strike="noStrike" dirty="0">
-                        <a:solidFill>
-                          <a:srgbClr val="000000"/>
-                        </a:solidFill>
-                        <a:effectLst/>
-                        <a:latin typeface="Aptos Narrow"/>
-                      </a:endParaRPr>
-                    </a:p>
-                  </a:txBody>
-                  <a:tcPr marL="7620" marR="7620" marT="7620" marB="0" anchor="b"/>
-                </a:tc>
-                <a:tc>
-                  <a:txBody>
-                    <a:bodyPr/>
-                    <a:lstStyle/>
-                    <a:p>
-                      <a:pPr algn="l" fontAlgn="b"/>
-                      <a:endParaRPr lang="en-IN" sz="1400" b="0" i="0" u="none" strike="noStrike" dirty="0">
-                        <a:solidFill>
-                          <a:srgbClr val="000000"/>
-                        </a:solidFill>
-                        <a:effectLst/>
-                        <a:latin typeface="Aptos Narrow"/>
-                      </a:endParaRPr>
-                    </a:p>
-                  </a:txBody>
-                  <a:tcPr marL="7620" marR="7620" marT="7620" marB="0" anchor="b"/>
-                </a:tc>
-                <a:extLst>
-                  <a:ext uri="{0D108BD9-81ED-4DB2-BD59-A6C34878D82A}">
-                    <a16:rowId xmlns:a16="http://schemas.microsoft.com/office/drawing/2014/main" val="1368431794"/>
-                  </a:ext>
-                </a:extLst>
-              </a:tr>
-              <a:tr h="282909">
-                <a:tc>
-                  <a:txBody>
-                    <a:bodyPr/>
-                    <a:lstStyle/>
-                    <a:p>
-                      <a:pPr algn="l" fontAlgn="b"/>
-                      <a:r>
-                        <a:rPr lang="en-IN" sz="1400" u="none" strike="noStrike" dirty="0">
-                          <a:effectLst/>
-                        </a:rPr>
-                        <a:t> </a:t>
-                      </a:r>
-                      <a:r>
-                        <a:rPr lang="en-US" sz="1400" dirty="0"/>
-                        <a:t>State, Event Handlers, Chatbot Project Features </a:t>
-                      </a:r>
-                      <a:endParaRPr lang="en-IN" sz="1400" b="0" i="0" u="none" strike="noStrike" dirty="0">
-                        <a:solidFill>
-                          <a:srgbClr val="000000"/>
-                        </a:solidFill>
-                        <a:effectLst/>
-                        <a:latin typeface="Aptos Narrow"/>
-                      </a:endParaRPr>
-                    </a:p>
-                  </a:txBody>
-                  <a:tcPr marL="7620" marR="7620" marT="7620" marB="0" anchor="b"/>
-                </a:tc>
                 <a:tc rowSpan="2">
                   <a:txBody>
                     <a:bodyPr/>
@@ -4427,6 +4436,12 @@
                     <a:lstStyle/>
                     <a:p>
                       <a:pPr algn="ctr" fontAlgn="b"/>
+                      <a:r>
+                        <a:rPr lang="en-IN" sz="1400" u="none" strike="noStrike" dirty="0">
+                          <a:effectLst/>
+                        </a:rPr>
+                        <a:t>DONE</a:t>
+                      </a:r>
                       <a:endParaRPr lang="en-IN" sz="1400" b="0" i="0" u="none" strike="noStrike" dirty="0">
                         <a:solidFill>
                           <a:srgbClr val="000000"/>
@@ -4501,13 +4516,7 @@
                     <a:lstStyle/>
                     <a:p>
                       <a:pPr algn="l" fontAlgn="b"/>
-                      <a:r>
-                        <a:rPr lang="en-IN" sz="1400" u="none" strike="noStrike">
-                          <a:effectLst/>
-                        </a:rPr>
-                        <a:t> </a:t>
-                      </a:r>
-                      <a:endParaRPr lang="en-IN" sz="1400" b="0" i="0" u="none" strike="noStrike">
+                      <a:endParaRPr lang="en-IN" sz="1400" b="0" i="0" u="none" strike="noStrike" dirty="0">
                         <a:solidFill>
                           <a:srgbClr val="000000"/>
                         </a:solidFill>

</xml_diff>

<commit_message>
chatbot appln done in react setup.New e commerce project started
</commit_message>
<xml_diff>
--- a/ROADMAP/roadmap react js.pptx
+++ b/ROADMAP/roadmap react js.pptx
@@ -264,7 +264,7 @@
           <a:p>
             <a:fld id="{3757B9D6-B1DD-42FC-8CF6-CEEED335747B}" type="datetimeFigureOut">
               <a:rPr lang="en-IN" smtClean="0"/>
-              <a:t>13-01-2026</a:t>
+              <a:t>07-03-2026</a:t>
             </a:fld>
             <a:endParaRPr lang="en-IN"/>
           </a:p>
@@ -464,7 +464,7 @@
           <a:p>
             <a:fld id="{3757B9D6-B1DD-42FC-8CF6-CEEED335747B}" type="datetimeFigureOut">
               <a:rPr lang="en-IN" smtClean="0"/>
-              <a:t>13-01-2026</a:t>
+              <a:t>07-03-2026</a:t>
             </a:fld>
             <a:endParaRPr lang="en-IN"/>
           </a:p>
@@ -674,7 +674,7 @@
           <a:p>
             <a:fld id="{3757B9D6-B1DD-42FC-8CF6-CEEED335747B}" type="datetimeFigureOut">
               <a:rPr lang="en-IN" smtClean="0"/>
-              <a:t>13-01-2026</a:t>
+              <a:t>07-03-2026</a:t>
             </a:fld>
             <a:endParaRPr lang="en-IN"/>
           </a:p>
@@ -874,7 +874,7 @@
           <a:p>
             <a:fld id="{3757B9D6-B1DD-42FC-8CF6-CEEED335747B}" type="datetimeFigureOut">
               <a:rPr lang="en-IN" smtClean="0"/>
-              <a:t>13-01-2026</a:t>
+              <a:t>07-03-2026</a:t>
             </a:fld>
             <a:endParaRPr lang="en-IN"/>
           </a:p>
@@ -1150,7 +1150,7 @@
           <a:p>
             <a:fld id="{3757B9D6-B1DD-42FC-8CF6-CEEED335747B}" type="datetimeFigureOut">
               <a:rPr lang="en-IN" smtClean="0"/>
-              <a:t>13-01-2026</a:t>
+              <a:t>07-03-2026</a:t>
             </a:fld>
             <a:endParaRPr lang="en-IN"/>
           </a:p>
@@ -1418,7 +1418,7 @@
           <a:p>
             <a:fld id="{3757B9D6-B1DD-42FC-8CF6-CEEED335747B}" type="datetimeFigureOut">
               <a:rPr lang="en-IN" smtClean="0"/>
-              <a:t>13-01-2026</a:t>
+              <a:t>07-03-2026</a:t>
             </a:fld>
             <a:endParaRPr lang="en-IN"/>
           </a:p>
@@ -1833,7 +1833,7 @@
           <a:p>
             <a:fld id="{3757B9D6-B1DD-42FC-8CF6-CEEED335747B}" type="datetimeFigureOut">
               <a:rPr lang="en-IN" smtClean="0"/>
-              <a:t>13-01-2026</a:t>
+              <a:t>07-03-2026</a:t>
             </a:fld>
             <a:endParaRPr lang="en-IN"/>
           </a:p>
@@ -1975,7 +1975,7 @@
           <a:p>
             <a:fld id="{3757B9D6-B1DD-42FC-8CF6-CEEED335747B}" type="datetimeFigureOut">
               <a:rPr lang="en-IN" smtClean="0"/>
-              <a:t>13-01-2026</a:t>
+              <a:t>07-03-2026</a:t>
             </a:fld>
             <a:endParaRPr lang="en-IN"/>
           </a:p>
@@ -2088,7 +2088,7 @@
           <a:p>
             <a:fld id="{3757B9D6-B1DD-42FC-8CF6-CEEED335747B}" type="datetimeFigureOut">
               <a:rPr lang="en-IN" smtClean="0"/>
-              <a:t>13-01-2026</a:t>
+              <a:t>07-03-2026</a:t>
             </a:fld>
             <a:endParaRPr lang="en-IN"/>
           </a:p>
@@ -2401,7 +2401,7 @@
           <a:p>
             <a:fld id="{3757B9D6-B1DD-42FC-8CF6-CEEED335747B}" type="datetimeFigureOut">
               <a:rPr lang="en-IN" smtClean="0"/>
-              <a:t>13-01-2026</a:t>
+              <a:t>07-03-2026</a:t>
             </a:fld>
             <a:endParaRPr lang="en-IN"/>
           </a:p>
@@ -2690,7 +2690,7 @@
           <a:p>
             <a:fld id="{3757B9D6-B1DD-42FC-8CF6-CEEED335747B}" type="datetimeFigureOut">
               <a:rPr lang="en-IN" smtClean="0"/>
-              <a:t>13-01-2026</a:t>
+              <a:t>07-03-2026</a:t>
             </a:fld>
             <a:endParaRPr lang="en-IN"/>
           </a:p>
@@ -2933,7 +2933,7 @@
           <a:p>
             <a:fld id="{3757B9D6-B1DD-42FC-8CF6-CEEED335747B}" type="datetimeFigureOut">
               <a:rPr lang="en-IN" smtClean="0"/>
-              <a:t>13-01-2026</a:t>
+              <a:t>07-03-2026</a:t>
             </a:fld>
             <a:endParaRPr lang="en-IN"/>
           </a:p>
@@ -3739,7 +3739,34 @@
               <a:rPr lang="en-US" dirty="0"/>
               <a:t>Conclusion and Next Steps</a:t>
             </a:r>
-            <a:endParaRPr lang="en-IN" dirty="0"/>
+          </a:p>
+          <a:p>
+            <a:pPr algn="ctr"/>
+            <a:r>
+              <a:rPr lang="en-US" dirty="0"/>
+              <a:t>Start the project using </a:t>
+            </a:r>
+            <a:r>
+              <a:rPr lang="en-US" dirty="0" err="1"/>
+              <a:t>npx</a:t>
+            </a:r>
+            <a:r>
+              <a:rPr lang="en-US" dirty="0"/>
+              <a:t> </a:t>
+            </a:r>
+            <a:r>
+              <a:rPr lang="en-US" dirty="0">
+                <a:highlight>
+                  <a:srgbClr val="FFFF00"/>
+                </a:highlight>
+              </a:rPr>
+              <a:t>create-vite@6.5.0</a:t>
+            </a:r>
+            <a:endParaRPr lang="en-IN" dirty="0">
+              <a:highlight>
+                <a:srgbClr val="FFFF00"/>
+              </a:highlight>
+            </a:endParaRPr>
           </a:p>
         </p:txBody>
       </p:sp>
@@ -3825,7 +3852,7 @@
             <p:ph idx="1"/>
             <p:extLst>
               <p:ext uri="{D42A27DB-BD31-4B8C-83A1-F6EECF244321}">
-                <p14:modId xmlns:p14="http://schemas.microsoft.com/office/powerpoint/2010/main" val="497159379"/>
+                <p14:modId xmlns:p14="http://schemas.microsoft.com/office/powerpoint/2010/main" val="2158924530"/>
               </p:ext>
             </p:extLst>
           </p:nvPr>
@@ -4621,13 +4648,16 @@
                     <a:lstStyle/>
                     <a:p>
                       <a:pPr algn="ctr" fontAlgn="b"/>
-                      <a:endParaRPr lang="en-IN" sz="1400" b="0" i="0" u="none" strike="noStrike" dirty="0">
-                        <a:solidFill>
-                          <a:srgbClr val="000000"/>
-                        </a:solidFill>
-                        <a:effectLst/>
-                        <a:latin typeface="Aptos Narrow"/>
-                      </a:endParaRPr>
+                      <a:r>
+                        <a:rPr lang="en-IN" sz="1400" b="0" i="0" u="none" strike="noStrike" dirty="0">
+                          <a:solidFill>
+                            <a:srgbClr val="000000"/>
+                          </a:solidFill>
+                          <a:effectLst/>
+                          <a:latin typeface="Aptos Narrow"/>
+                        </a:rPr>
+                        <a:t>DONE</a:t>
+                      </a:r>
                     </a:p>
                   </a:txBody>
                   <a:tcPr marL="7620" marR="7620" marT="7620" marB="0" anchor="b"/>
@@ -4798,13 +4828,16 @@
                     <a:lstStyle/>
                     <a:p>
                       <a:pPr algn="ctr" fontAlgn="b"/>
-                      <a:endParaRPr lang="en-IN" sz="1400" b="0" i="0" u="none" strike="noStrike" dirty="0">
-                        <a:solidFill>
-                          <a:srgbClr val="000000"/>
-                        </a:solidFill>
-                        <a:effectLst/>
-                        <a:latin typeface="Aptos Narrow"/>
-                      </a:endParaRPr>
+                      <a:r>
+                        <a:rPr lang="en-IN" sz="1400" b="0" i="0" u="none" strike="noStrike" dirty="0">
+                          <a:solidFill>
+                            <a:srgbClr val="000000"/>
+                          </a:solidFill>
+                          <a:effectLst/>
+                          <a:latin typeface="Aptos Narrow"/>
+                        </a:rPr>
+                        <a:t>DONE</a:t>
+                      </a:r>
                     </a:p>
                   </a:txBody>
                   <a:tcPr marL="7620" marR="7620" marT="7620" marB="0" anchor="b"/>
@@ -4959,7 +4992,7 @@
                           <a:effectLst/>
                           <a:latin typeface="Aptos Narrow"/>
                         </a:rPr>
-                        <a:t>16/01</a:t>
+                        <a:t>04/03</a:t>
                       </a:r>
                     </a:p>
                   </a:txBody>
@@ -5082,7 +5115,7 @@
             <p:ph idx="1"/>
             <p:extLst>
               <p:ext uri="{D42A27DB-BD31-4B8C-83A1-F6EECF244321}">
-                <p14:modId xmlns:p14="http://schemas.microsoft.com/office/powerpoint/2010/main" val="697453235"/>
+                <p14:modId xmlns:p14="http://schemas.microsoft.com/office/powerpoint/2010/main" val="822011400"/>
               </p:ext>
             </p:extLst>
           </p:nvPr>
@@ -5156,7 +5189,7 @@
                           <a:effectLst/>
                           <a:latin typeface="Aptos Narrow"/>
                         </a:rPr>
-                        <a:t>19/01</a:t>
+                        <a:t>06/03</a:t>
                       </a:r>
                     </a:p>
                   </a:txBody>
@@ -5333,7 +5366,7 @@
                           <a:effectLst/>
                           <a:latin typeface="Aptos Narrow"/>
                         </a:rPr>
-                        <a:t>20/01</a:t>
+                        <a:t>07/03</a:t>
                       </a:r>
                     </a:p>
                   </a:txBody>
@@ -5513,7 +5546,7 @@
                           <a:effectLst/>
                           <a:latin typeface="Aptos Narrow"/>
                         </a:rPr>
-                        <a:t>21/01</a:t>
+                        <a:t>09/03</a:t>
                       </a:r>
                     </a:p>
                   </a:txBody>
@@ -5642,7 +5675,7 @@
                           <a:effectLst/>
                           <a:latin typeface="Aptos Narrow"/>
                         </a:rPr>
-                        <a:t>23/01</a:t>
+                        <a:t>10/03</a:t>
                       </a:r>
                     </a:p>
                   </a:txBody>
@@ -5815,7 +5848,7 @@
                           <a:effectLst/>
                           <a:latin typeface="Aptos Narrow"/>
                         </a:rPr>
-                        <a:t>26/01</a:t>
+                        <a:t>11/03</a:t>
                       </a:r>
                     </a:p>
                   </a:txBody>
@@ -5992,7 +6025,7 @@
                           <a:effectLst/>
                           <a:latin typeface="Aptos Narrow"/>
                         </a:rPr>
-                        <a:t>27/01</a:t>
+                        <a:t>13/03</a:t>
                       </a:r>
                     </a:p>
                   </a:txBody>
@@ -6177,7 +6210,7 @@
                           <a:effectLst/>
                           <a:latin typeface="Aptos Narrow"/>
                         </a:rPr>
-                        <a:t>28/01</a:t>
+                        <a:t>14/03</a:t>
                       </a:r>
                     </a:p>
                   </a:txBody>
@@ -6367,7 +6400,7 @@
                           <a:effectLst/>
                           <a:latin typeface="Aptos Narrow"/>
                         </a:rPr>
-                        <a:t>             30/01</a:t>
+                        <a:t>             16/03</a:t>
                       </a:r>
                     </a:p>
                   </a:txBody>
@@ -6503,7 +6536,7 @@
                           <a:effectLst/>
                           <a:latin typeface="Aptos Narrow"/>
                         </a:rPr>
-                        <a:t>02/02</a:t>
+                        <a:t>17/03</a:t>
                       </a:r>
                     </a:p>
                   </a:txBody>

</xml_diff>

<commit_message>
split header into a component and use link
</commit_message>
<xml_diff>
--- a/ROADMAP/roadmap react js.pptx
+++ b/ROADMAP/roadmap react js.pptx
@@ -264,7 +264,7 @@
           <a:p>
             <a:fld id="{3757B9D6-B1DD-42FC-8CF6-CEEED335747B}" type="datetimeFigureOut">
               <a:rPr lang="en-IN" smtClean="0"/>
-              <a:t>07-03-2026</a:t>
+              <a:t>10-03-2026</a:t>
             </a:fld>
             <a:endParaRPr lang="en-IN"/>
           </a:p>
@@ -464,7 +464,7 @@
           <a:p>
             <a:fld id="{3757B9D6-B1DD-42FC-8CF6-CEEED335747B}" type="datetimeFigureOut">
               <a:rPr lang="en-IN" smtClean="0"/>
-              <a:t>07-03-2026</a:t>
+              <a:t>10-03-2026</a:t>
             </a:fld>
             <a:endParaRPr lang="en-IN"/>
           </a:p>
@@ -674,7 +674,7 @@
           <a:p>
             <a:fld id="{3757B9D6-B1DD-42FC-8CF6-CEEED335747B}" type="datetimeFigureOut">
               <a:rPr lang="en-IN" smtClean="0"/>
-              <a:t>07-03-2026</a:t>
+              <a:t>10-03-2026</a:t>
             </a:fld>
             <a:endParaRPr lang="en-IN"/>
           </a:p>
@@ -874,7 +874,7 @@
           <a:p>
             <a:fld id="{3757B9D6-B1DD-42FC-8CF6-CEEED335747B}" type="datetimeFigureOut">
               <a:rPr lang="en-IN" smtClean="0"/>
-              <a:t>07-03-2026</a:t>
+              <a:t>10-03-2026</a:t>
             </a:fld>
             <a:endParaRPr lang="en-IN"/>
           </a:p>
@@ -1150,7 +1150,7 @@
           <a:p>
             <a:fld id="{3757B9D6-B1DD-42FC-8CF6-CEEED335747B}" type="datetimeFigureOut">
               <a:rPr lang="en-IN" smtClean="0"/>
-              <a:t>07-03-2026</a:t>
+              <a:t>10-03-2026</a:t>
             </a:fld>
             <a:endParaRPr lang="en-IN"/>
           </a:p>
@@ -1418,7 +1418,7 @@
           <a:p>
             <a:fld id="{3757B9D6-B1DD-42FC-8CF6-CEEED335747B}" type="datetimeFigureOut">
               <a:rPr lang="en-IN" smtClean="0"/>
-              <a:t>07-03-2026</a:t>
+              <a:t>10-03-2026</a:t>
             </a:fld>
             <a:endParaRPr lang="en-IN"/>
           </a:p>
@@ -1833,7 +1833,7 @@
           <a:p>
             <a:fld id="{3757B9D6-B1DD-42FC-8CF6-CEEED335747B}" type="datetimeFigureOut">
               <a:rPr lang="en-IN" smtClean="0"/>
-              <a:t>07-03-2026</a:t>
+              <a:t>10-03-2026</a:t>
             </a:fld>
             <a:endParaRPr lang="en-IN"/>
           </a:p>
@@ -1975,7 +1975,7 @@
           <a:p>
             <a:fld id="{3757B9D6-B1DD-42FC-8CF6-CEEED335747B}" type="datetimeFigureOut">
               <a:rPr lang="en-IN" smtClean="0"/>
-              <a:t>07-03-2026</a:t>
+              <a:t>10-03-2026</a:t>
             </a:fld>
             <a:endParaRPr lang="en-IN"/>
           </a:p>
@@ -2088,7 +2088,7 @@
           <a:p>
             <a:fld id="{3757B9D6-B1DD-42FC-8CF6-CEEED335747B}" type="datetimeFigureOut">
               <a:rPr lang="en-IN" smtClean="0"/>
-              <a:t>07-03-2026</a:t>
+              <a:t>10-03-2026</a:t>
             </a:fld>
             <a:endParaRPr lang="en-IN"/>
           </a:p>
@@ -2401,7 +2401,7 @@
           <a:p>
             <a:fld id="{3757B9D6-B1DD-42FC-8CF6-CEEED335747B}" type="datetimeFigureOut">
               <a:rPr lang="en-IN" smtClean="0"/>
-              <a:t>07-03-2026</a:t>
+              <a:t>10-03-2026</a:t>
             </a:fld>
             <a:endParaRPr lang="en-IN"/>
           </a:p>
@@ -2690,7 +2690,7 @@
           <a:p>
             <a:fld id="{3757B9D6-B1DD-42FC-8CF6-CEEED335747B}" type="datetimeFigureOut">
               <a:rPr lang="en-IN" smtClean="0"/>
-              <a:t>07-03-2026</a:t>
+              <a:t>10-03-2026</a:t>
             </a:fld>
             <a:endParaRPr lang="en-IN"/>
           </a:p>
@@ -2933,7 +2933,7 @@
           <a:p>
             <a:fld id="{3757B9D6-B1DD-42FC-8CF6-CEEED335747B}" type="datetimeFigureOut">
               <a:rPr lang="en-IN" smtClean="0"/>
-              <a:t>07-03-2026</a:t>
+              <a:t>10-03-2026</a:t>
             </a:fld>
             <a:endParaRPr lang="en-IN"/>
           </a:p>
@@ -3852,7 +3852,7 @@
             <p:ph idx="1"/>
             <p:extLst>
               <p:ext uri="{D42A27DB-BD31-4B8C-83A1-F6EECF244321}">
-                <p14:modId xmlns:p14="http://schemas.microsoft.com/office/powerpoint/2010/main" val="2158924530"/>
+                <p14:modId xmlns:p14="http://schemas.microsoft.com/office/powerpoint/2010/main" val="626122077"/>
               </p:ext>
             </p:extLst>
           </p:nvPr>
@@ -5004,6 +5004,16 @@
                     <a:lstStyle/>
                     <a:p>
                       <a:pPr algn="ctr" fontAlgn="b"/>
+                      <a:r>
+                        <a:rPr lang="en-US" sz="1400" b="0" i="0" u="none" strike="noStrike" dirty="0">
+                          <a:solidFill>
+                            <a:srgbClr val="000000"/>
+                          </a:solidFill>
+                          <a:effectLst/>
+                          <a:latin typeface="Aptos Narrow"/>
+                        </a:rPr>
+                        <a:t>DONE</a:t>
+                      </a:r>
                       <a:endParaRPr lang="en-IN" sz="1400" b="0" i="0" u="none" strike="noStrike" dirty="0">
                         <a:solidFill>
                           <a:srgbClr val="000000"/>
@@ -5115,7 +5125,7 @@
             <p:ph idx="1"/>
             <p:extLst>
               <p:ext uri="{D42A27DB-BD31-4B8C-83A1-F6EECF244321}">
-                <p14:modId xmlns:p14="http://schemas.microsoft.com/office/powerpoint/2010/main" val="822011400"/>
+                <p14:modId xmlns:p14="http://schemas.microsoft.com/office/powerpoint/2010/main" val="4009865976"/>
               </p:ext>
             </p:extLst>
           </p:nvPr>
@@ -5201,6 +5211,16 @@
                     <a:lstStyle/>
                     <a:p>
                       <a:pPr algn="ctr" fontAlgn="b"/>
+                      <a:r>
+                        <a:rPr lang="en-US" sz="1400" b="0" i="0" u="none" strike="noStrike" dirty="0">
+                          <a:solidFill>
+                            <a:srgbClr val="000000"/>
+                          </a:solidFill>
+                          <a:effectLst/>
+                          <a:latin typeface="Aptos Narrow"/>
+                        </a:rPr>
+                        <a:t>DONE</a:t>
+                      </a:r>
                       <a:endParaRPr lang="en-IN" sz="1400" b="0" i="0" u="none" strike="noStrike" dirty="0">
                         <a:solidFill>
                           <a:srgbClr val="000000"/>
@@ -5378,6 +5398,16 @@
                     <a:lstStyle/>
                     <a:p>
                       <a:pPr algn="ctr" fontAlgn="b"/>
+                      <a:r>
+                        <a:rPr lang="en-US" sz="1400" b="0" i="0" u="none" strike="noStrike" dirty="0">
+                          <a:solidFill>
+                            <a:srgbClr val="000000"/>
+                          </a:solidFill>
+                          <a:effectLst/>
+                          <a:latin typeface="Aptos Narrow"/>
+                        </a:rPr>
+                        <a:t>DONE</a:t>
+                      </a:r>
                       <a:endParaRPr lang="en-IN" sz="1400" b="0" i="0" u="none" strike="noStrike" dirty="0">
                         <a:solidFill>
                           <a:srgbClr val="000000"/>

</xml_diff>